<commit_message>
feat: improve visual audit and examples
</commit_message>
<xml_diff>
--- a/examples/templates/branddocs_template.pptx
+++ b/examples/templates/branddocs_template.pptx
@@ -14,6 +14,8 @@
     <p:sldId id="262" r:id="rId13"/>
     <p:sldId id="263" r:id="rId14"/>
     <p:sldId id="264" r:id="rId15"/>
+    <p:sldId id="265" r:id="rId16"/>
+    <p:sldId id="266" r:id="rId17"/>
   </p:sldIdLst>
   <p:sldSz cx="9144000" cy="6858000" type="screen4x3"/>
   <p:notesSz cx="6858000" cy="9144000"/>
@@ -120,20 +122,22 @@
             <p14:sldId id="256"/>
             <p14:sldId id="257"/>
             <p14:sldId id="258"/>
+            <p14:sldId id="259"/>
           </p14:sldIdLst>
         </p14:section>
         <p14:section name="Financials" id="{00000002-0000-4000-8000-000000000002}">
           <p14:sldIdLst>
-            <p14:sldId id="259"/>
             <p14:sldId id="260"/>
+            <p14:sldId id="261"/>
+            <p14:sldId id="262"/>
           </p14:sldIdLst>
         </p14:section>
         <p14:section name="Closing" id="{00000003-0000-4000-8000-000000000003}">
           <p14:sldIdLst>
-            <p14:sldId id="261"/>
-            <p14:sldId id="262"/>
             <p14:sldId id="263"/>
             <p14:sldId id="264"/>
+            <p14:sldId id="265"/>
+            <p14:sldId id="266"/>
           </p14:sldIdLst>
         </p14:section>
       </p14:sectionLst>
@@ -143,6 +147,242 @@
 </file>
 
 <file path=ppt/charts/chart1.xml><?xml version="1.0" encoding="utf-8"?>
+<c:chartSpace xmlns:c="http://schemas.openxmlformats.org/drawingml/2006/chart" xmlns:a="http://schemas.openxmlformats.org/drawingml/2006/main" xmlns:r="http://schemas.openxmlformats.org/officeDocument/2006/relationships">
+  <c:date1904 val="0"/>
+  <c:chart>
+    <c:title>
+      <c:tx>
+        <c:rich>
+          <a:bodyPr/>
+          <a:lstStyle/>
+          <a:p>
+            <a:r>
+              <a:t>Health and adoption trend</a:t>
+            </a:r>
+          </a:p>
+        </c:rich>
+      </c:tx>
+      <c:layout/>
+      <c:overlay val="0"/>
+    </c:title>
+    <c:autoTitleDeleted val="0"/>
+    <c:plotArea>
+      <c:lineChart>
+        <c:grouping val="standard"/>
+        <c:varyColors val="0"/>
+        <c:ser>
+          <c:idx val="0"/>
+          <c:order val="0"/>
+          <c:tx>
+            <c:strRef>
+              <c:f>Sheet1!$B$1</c:f>
+              <c:strCache>
+                <c:ptCount val="1"/>
+                <c:pt idx="0">
+                  <c:v>Brand health</c:v>
+                </c:pt>
+              </c:strCache>
+            </c:strRef>
+          </c:tx>
+          <c:spPr>
+            <a:ln w="28575">
+              <a:solidFill>
+                <a:srgbClr val="2B7CD3"/>
+              </a:solidFill>
+            </a:ln>
+          </c:spPr>
+          <c:cat>
+            <c:strRef>
+              <c:f>Sheet1!$A$2:$A$7</c:f>
+              <c:strCache>
+                <c:ptCount val="6"/>
+                <c:pt idx="0">
+                  <c:v>Jan</c:v>
+                </c:pt>
+                <c:pt idx="1">
+                  <c:v>Feb</c:v>
+                </c:pt>
+                <c:pt idx="2">
+                  <c:v>Mar</c:v>
+                </c:pt>
+                <c:pt idx="3">
+                  <c:v>Apr</c:v>
+                </c:pt>
+                <c:pt idx="4">
+                  <c:v>May</c:v>
+                </c:pt>
+                <c:pt idx="5">
+                  <c:v>Jun</c:v>
+                </c:pt>
+              </c:strCache>
+            </c:strRef>
+          </c:cat>
+          <c:val>
+            <c:numRef>
+              <c:f>Sheet1!$B$2:$B$7</c:f>
+              <c:numCache>
+                <c:formatCode>General</c:formatCode>
+                <c:ptCount val="6"/>
+                <c:pt idx="0">
+                  <c:v>74</c:v>
+                </c:pt>
+                <c:pt idx="1">
+                  <c:v>78</c:v>
+                </c:pt>
+                <c:pt idx="2">
+                  <c:v>81</c:v>
+                </c:pt>
+                <c:pt idx="3">
+                  <c:v>84</c:v>
+                </c:pt>
+                <c:pt idx="4">
+                  <c:v>88</c:v>
+                </c:pt>
+                <c:pt idx="5">
+                  <c:v>92</c:v>
+                </c:pt>
+              </c:numCache>
+            </c:numRef>
+          </c:val>
+          <c:smooth val="0"/>
+        </c:ser>
+        <c:ser>
+          <c:idx val="1"/>
+          <c:order val="1"/>
+          <c:tx>
+            <c:strRef>
+              <c:f>Sheet1!$C$1</c:f>
+              <c:strCache>
+                <c:ptCount val="1"/>
+                <c:pt idx="0">
+                  <c:v>Adoption</c:v>
+                </c:pt>
+              </c:strCache>
+            </c:strRef>
+          </c:tx>
+          <c:spPr>
+            <a:ln w="28575">
+              <a:solidFill>
+                <a:srgbClr val="E0742B"/>
+              </a:solidFill>
+            </a:ln>
+          </c:spPr>
+          <c:cat>
+            <c:strRef>
+              <c:f>Sheet1!$A$2:$A$7</c:f>
+              <c:strCache>
+                <c:ptCount val="6"/>
+                <c:pt idx="0">
+                  <c:v>Jan</c:v>
+                </c:pt>
+                <c:pt idx="1">
+                  <c:v>Feb</c:v>
+                </c:pt>
+                <c:pt idx="2">
+                  <c:v>Mar</c:v>
+                </c:pt>
+                <c:pt idx="3">
+                  <c:v>Apr</c:v>
+                </c:pt>
+                <c:pt idx="4">
+                  <c:v>May</c:v>
+                </c:pt>
+                <c:pt idx="5">
+                  <c:v>Jun</c:v>
+                </c:pt>
+              </c:strCache>
+            </c:strRef>
+          </c:cat>
+          <c:val>
+            <c:numRef>
+              <c:f>Sheet1!$C$2:$C$7</c:f>
+              <c:numCache>
+                <c:formatCode>General</c:formatCode>
+                <c:ptCount val="6"/>
+                <c:pt idx="0">
+                  <c:v>61</c:v>
+                </c:pt>
+                <c:pt idx="1">
+                  <c:v>66</c:v>
+                </c:pt>
+                <c:pt idx="2">
+                  <c:v>70</c:v>
+                </c:pt>
+                <c:pt idx="3">
+                  <c:v>76</c:v>
+                </c:pt>
+                <c:pt idx="4">
+                  <c:v>81</c:v>
+                </c:pt>
+                <c:pt idx="5">
+                  <c:v>86</c:v>
+                </c:pt>
+              </c:numCache>
+            </c:numRef>
+          </c:val>
+          <c:smooth val="0"/>
+        </c:ser>
+        <c:marker val="1"/>
+        <c:smooth val="0"/>
+        <c:axId val="2118791784"/>
+        <c:axId val="2140495176"/>
+      </c:lineChart>
+      <c:catAx>
+        <c:axId val="2118791784"/>
+        <c:scaling>
+          <c:orientation val="minMax"/>
+        </c:scaling>
+        <c:delete val="0"/>
+        <c:axPos val="b"/>
+        <c:majorTickMark val="out"/>
+        <c:minorTickMark val="none"/>
+        <c:tickLblPos val="nextTo"/>
+        <c:crossAx val="2140495176"/>
+        <c:crosses val="autoZero"/>
+        <c:auto val="1"/>
+        <c:lblAlgn val="ctr"/>
+        <c:lblOffset val="100"/>
+        <c:noMultiLvlLbl val="0"/>
+      </c:catAx>
+      <c:valAx>
+        <c:axId val="2140495176"/>
+        <c:scaling/>
+        <c:delete val="0"/>
+        <c:axPos val="l"/>
+        <c:majorGridlines/>
+        <c:majorTickMark val="out"/>
+        <c:minorTickMark val="none"/>
+        <c:tickLblPos val="nextTo"/>
+        <c:crossAx val="2118791784"/>
+        <c:crosses val="autoZero"/>
+      </c:valAx>
+    </c:plotArea>
+    <c:legend>
+      <c:legendPos val="b"/>
+      <c:layout/>
+      <c:overlay val="0"/>
+    </c:legend>
+    <c:plotVisOnly val="1"/>
+    <c:dispBlanksAs val="gap"/>
+    <c:showDLblsOverMax val="0"/>
+  </c:chart>
+  <c:txPr>
+    <a:bodyPr/>
+    <a:lstStyle/>
+    <a:p>
+      <a:pPr>
+        <a:defRPr sz="1800"/>
+      </a:pPr>
+      <a:endParaRPr lang="en-US"/>
+    </a:p>
+  </c:txPr>
+  <c:externalData r:id="rId1">
+    <c:autoUpdate val="0"/>
+  </c:externalData>
+</c:chartSpace>
+</file>
+
+<file path=ppt/charts/chart2.xml><?xml version="1.0" encoding="utf-8"?>
 <c:chartSpace xmlns:c="http://schemas.openxmlformats.org/drawingml/2006/chart" xmlns:a="http://schemas.openxmlformats.org/drawingml/2006/main" xmlns:r="http://schemas.openxmlformats.org/officeDocument/2006/relationships">
   <c:date1904 val="0"/>
   <c:chart>
@@ -3428,7 +3668,7 @@
       <p:grpSpPr/>
       <p:sp>
         <p:nvSpPr>
-          <p:cNvPr id="6" name="Rectangle 5"/>
+          <p:cNvPr id="8" name="Rectangle 7"/>
           <p:cNvSpPr/>
           <p:nvPr/>
         </p:nvSpPr>
@@ -3472,6 +3712,94 @@
       </p:sp>
       <p:sp>
         <p:nvSpPr>
+          <p:cNvPr id="7" name="Rectangle 6"/>
+          <p:cNvSpPr/>
+          <p:nvPr/>
+        </p:nvSpPr>
+        <p:spPr>
+          <a:xfrm>
+            <a:off x="6537960" y="0"/>
+            <a:ext cx="91440" cy="6858000"/>
+          </a:xfrm>
+          <a:prstGeom prst="rect">
+            <a:avLst/>
+          </a:prstGeom>
+          <a:solidFill>
+            <a:srgbClr val="E0742B"/>
+          </a:solidFill>
+          <a:ln>
+            <a:noFill/>
+          </a:ln>
+          <a:effectLst/>
+        </p:spPr>
+        <p:style>
+          <a:lnRef idx="1">
+            <a:schemeClr val="accent1"/>
+          </a:lnRef>
+          <a:fillRef idx="3">
+            <a:schemeClr val="accent1"/>
+          </a:fillRef>
+          <a:effectRef idx="2">
+            <a:schemeClr val="accent1"/>
+          </a:effectRef>
+          <a:fontRef idx="minor">
+            <a:schemeClr val="lt1"/>
+          </a:fontRef>
+        </p:style>
+        <p:txBody>
+          <a:bodyPr rtlCol="0" anchor="ctr"/>
+          <a:lstStyle/>
+          <a:p>
+            <a:pPr algn="ctr"/>
+          </a:p>
+        </p:txBody>
+      </p:sp>
+      <p:sp>
+        <p:nvSpPr>
+          <p:cNvPr id="6" name="Rectangle 5"/>
+          <p:cNvSpPr/>
+          <p:nvPr/>
+        </p:nvSpPr>
+        <p:spPr>
+          <a:xfrm>
+            <a:off x="6629400" y="0"/>
+            <a:ext cx="2514600" cy="6858000"/>
+          </a:xfrm>
+          <a:prstGeom prst="rect">
+            <a:avLst/>
+          </a:prstGeom>
+          <a:solidFill>
+            <a:srgbClr val="16213F"/>
+          </a:solidFill>
+          <a:ln>
+            <a:noFill/>
+          </a:ln>
+          <a:effectLst/>
+        </p:spPr>
+        <p:style>
+          <a:lnRef idx="1">
+            <a:schemeClr val="accent1"/>
+          </a:lnRef>
+          <a:fillRef idx="3">
+            <a:schemeClr val="accent1"/>
+          </a:fillRef>
+          <a:effectRef idx="2">
+            <a:schemeClr val="accent1"/>
+          </a:effectRef>
+          <a:fontRef idx="minor">
+            <a:schemeClr val="lt1"/>
+          </a:fontRef>
+        </p:style>
+        <p:txBody>
+          <a:bodyPr rtlCol="0" anchor="ctr"/>
+          <a:lstStyle/>
+          <a:p>
+            <a:pPr algn="ctr"/>
+          </a:p>
+        </p:txBody>
+      </p:sp>
+      <p:sp>
+        <p:nvSpPr>
           <p:cNvPr id="5" name="Rectangle 4"/>
           <p:cNvSpPr/>
           <p:nvPr/>
@@ -3570,7 +3898,8 @@
         </p:nvSpPr>
         <p:spPr>
           <a:xfrm>
-            <a:off x="0" y="2057400"/>
+            <a:off x="182880" y="2057400"/>
+            <a:ext cx="5943600" cy="0"/>
           </a:xfrm>
         </p:spPr>
         <p:txBody>
@@ -3600,7 +3929,8 @@
         </p:nvSpPr>
         <p:spPr>
           <a:xfrm>
-            <a:off x="0" y="3429000"/>
+            <a:off x="685800" y="3429000"/>
+            <a:ext cx="5486400" cy="0"/>
           </a:xfrm>
         </p:spPr>
         <p:txBody>
@@ -3620,7 +3950,7 @@
       </p:sp>
       <p:pic>
         <p:nvPicPr>
-          <p:cNvPr id="7" name="Picture 6" descr="branddocs_template_mark.png"/>
+          <p:cNvPr id="9" name="Picture 8" descr="branddocs_template_wordmark.png"/>
           <p:cNvPicPr>
             <a:picLocks noChangeAspect="1"/>
           </p:cNvPicPr>
@@ -3634,14 +3964,200 @@
         </p:blipFill>
         <p:spPr>
           <a:xfrm>
-            <a:off x="457200" y="457200"/>
-            <a:ext cx="914400" cy="914400"/>
+            <a:off x="365760" y="548640"/>
+            <a:ext cx="1645920" cy="411480"/>
           </a:xfrm>
           <a:prstGeom prst="rect">
             <a:avLst/>
           </a:prstGeom>
         </p:spPr>
       </p:pic>
+      <p:sp>
+        <p:nvSpPr>
+          <p:cNvPr id="10" name="Rounded Rectangle 9"/>
+          <p:cNvSpPr/>
+          <p:nvPr/>
+        </p:nvSpPr>
+        <p:spPr>
+          <a:xfrm>
+            <a:off x="6903720" y="1371600"/>
+            <a:ext cx="1943100" cy="823000"/>
+          </a:xfrm>
+          <a:prstGeom prst="roundRect">
+            <a:avLst/>
+          </a:prstGeom>
+          <a:solidFill>
+            <a:srgbClr val="2B7CD3"/>
+          </a:solidFill>
+          <a:ln>
+            <a:noFill/>
+          </a:ln>
+          <a:effectLst/>
+        </p:spPr>
+        <p:style>
+          <a:lnRef idx="1">
+            <a:schemeClr val="accent1"/>
+          </a:lnRef>
+          <a:fillRef idx="3">
+            <a:schemeClr val="accent1"/>
+          </a:fillRef>
+          <a:effectRef idx="2">
+            <a:schemeClr val="accent1"/>
+          </a:effectRef>
+          <a:fontRef idx="minor">
+            <a:schemeClr val="lt1"/>
+          </a:fontRef>
+        </p:style>
+        <p:txBody>
+          <a:bodyPr rtlCol="0" anchor="ctr" lIns="137160" rIns="137160" tIns="91440" bIns="91440"/>
+          <a:lstStyle/>
+          <a:p>
+            <a:pPr algn="ctr"/>
+            <a:r>
+              <a:rPr sz="2400" b="1">
+                <a:solidFill>
+                  <a:srgbClr val="FFFFFF"/>
+                </a:solidFill>
+              </a:rPr>
+              <a:t>18%</a:t>
+            </a:r>
+          </a:p>
+          <a:p>
+            <a:r>
+              <a:rPr sz="1050" b="1">
+                <a:solidFill>
+                  <a:srgbClr val="FFFFFF"/>
+                </a:solidFill>
+              </a:rPr>
+              <a:t>YoY revenue growth</a:t>
+            </a:r>
+          </a:p>
+        </p:txBody>
+      </p:sp>
+      <p:sp>
+        <p:nvSpPr>
+          <p:cNvPr id="11" name="Rounded Rectangle 10"/>
+          <p:cNvSpPr/>
+          <p:nvPr/>
+        </p:nvSpPr>
+        <p:spPr>
+          <a:xfrm>
+            <a:off x="6903720" y="2453640"/>
+            <a:ext cx="1943100" cy="823000"/>
+          </a:xfrm>
+          <a:prstGeom prst="roundRect">
+            <a:avLst/>
+          </a:prstGeom>
+          <a:solidFill>
+            <a:srgbClr val="EAF1FF"/>
+          </a:solidFill>
+          <a:ln>
+            <a:noFill/>
+          </a:ln>
+          <a:effectLst/>
+        </p:spPr>
+        <p:style>
+          <a:lnRef idx="1">
+            <a:schemeClr val="accent1"/>
+          </a:lnRef>
+          <a:fillRef idx="3">
+            <a:schemeClr val="accent1"/>
+          </a:fillRef>
+          <a:effectRef idx="2">
+            <a:schemeClr val="accent1"/>
+          </a:effectRef>
+          <a:fontRef idx="minor">
+            <a:schemeClr val="lt1"/>
+          </a:fontRef>
+        </p:style>
+        <p:txBody>
+          <a:bodyPr rtlCol="0" anchor="ctr" lIns="137160" rIns="137160" tIns="91440" bIns="91440"/>
+          <a:lstStyle/>
+          <a:p>
+            <a:pPr algn="ctr"/>
+            <a:r>
+              <a:rPr sz="2400" b="1">
+                <a:solidFill>
+                  <a:srgbClr val="16213F"/>
+                </a:solidFill>
+              </a:rPr>
+              <a:t>92</a:t>
+            </a:r>
+          </a:p>
+          <a:p>
+            <a:r>
+              <a:rPr sz="1050" b="1">
+                <a:solidFill>
+                  <a:srgbClr val="5778B0"/>
+                </a:solidFill>
+              </a:rPr>
+              <a:t>Brand health index</a:t>
+            </a:r>
+          </a:p>
+        </p:txBody>
+      </p:sp>
+      <p:sp>
+        <p:nvSpPr>
+          <p:cNvPr id="12" name="Rounded Rectangle 11"/>
+          <p:cNvSpPr/>
+          <p:nvPr/>
+        </p:nvSpPr>
+        <p:spPr>
+          <a:xfrm>
+            <a:off x="6903720" y="3535680"/>
+            <a:ext cx="1943100" cy="823000"/>
+          </a:xfrm>
+          <a:prstGeom prst="roundRect">
+            <a:avLst/>
+          </a:prstGeom>
+          <a:solidFill>
+            <a:srgbClr val="E0742B"/>
+          </a:solidFill>
+          <a:ln>
+            <a:noFill/>
+          </a:ln>
+          <a:effectLst/>
+        </p:spPr>
+        <p:style>
+          <a:lnRef idx="1">
+            <a:schemeClr val="accent1"/>
+          </a:lnRef>
+          <a:fillRef idx="3">
+            <a:schemeClr val="accent1"/>
+          </a:fillRef>
+          <a:effectRef idx="2">
+            <a:schemeClr val="accent1"/>
+          </a:effectRef>
+          <a:fontRef idx="minor">
+            <a:schemeClr val="lt1"/>
+          </a:fontRef>
+        </p:style>
+        <p:txBody>
+          <a:bodyPr rtlCol="0" anchor="ctr" lIns="137160" rIns="137160" tIns="91440" bIns="91440"/>
+          <a:lstStyle/>
+          <a:p>
+            <a:pPr algn="ctr"/>
+            <a:r>
+              <a:rPr sz="2400" b="1">
+                <a:solidFill>
+                  <a:srgbClr val="FFFFFF"/>
+                </a:solidFill>
+              </a:rPr>
+              <a:t>3</a:t>
+            </a:r>
+          </a:p>
+          <a:p>
+            <a:r>
+              <a:rPr sz="1050" b="1">
+                <a:solidFill>
+                  <a:srgbClr val="FFFFFF"/>
+                </a:solidFill>
+              </a:rPr>
+              <a:t>Office formats audited</a:t>
+            </a:r>
+          </a:p>
+        </p:txBody>
+      </p:sp>
     </p:spTree>
   </p:cSld>
   <p:clrMapOvr>
@@ -3650,7 +4166,178 @@
 </p:sld>
 </file>
 
-<file path=ppt/slides/slide2.xml><?xml version="1.0" encoding="utf-8"?>
+<file path=ppt/slides/slide10.xml><?xml version="1.0" encoding="utf-8"?>
+<p:sld xmlns:a="http://schemas.openxmlformats.org/drawingml/2006/main" xmlns:p="http://schemas.openxmlformats.org/presentationml/2006/main" xmlns:r="http://schemas.openxmlformats.org/officeDocument/2006/relationships">
+  <p:cSld>
+    <p:spTree>
+      <p:nvGrpSpPr>
+        <p:cNvPr id="1" name=""/>
+        <p:cNvGrpSpPr/>
+        <p:nvPr/>
+      </p:nvGrpSpPr>
+      <p:grpSpPr/>
+      <p:sp>
+        <p:nvSpPr>
+          <p:cNvPr id="5" name="Rectangle 4"/>
+          <p:cNvSpPr/>
+          <p:nvPr/>
+        </p:nvSpPr>
+        <p:spPr>
+          <a:xfrm>
+            <a:off x="0" y="6629400"/>
+            <a:ext cx="9144000" cy="228600"/>
+          </a:xfrm>
+          <a:prstGeom prst="rect">
+            <a:avLst/>
+          </a:prstGeom>
+          <a:solidFill>
+            <a:srgbClr val="16213F"/>
+          </a:solidFill>
+          <a:ln>
+            <a:noFill/>
+          </a:ln>
+          <a:effectLst/>
+        </p:spPr>
+        <p:style>
+          <a:lnRef idx="1">
+            <a:schemeClr val="accent1"/>
+          </a:lnRef>
+          <a:fillRef idx="3">
+            <a:schemeClr val="accent1"/>
+          </a:fillRef>
+          <a:effectRef idx="2">
+            <a:schemeClr val="accent1"/>
+          </a:effectRef>
+          <a:fontRef idx="minor">
+            <a:schemeClr val="lt1"/>
+          </a:fontRef>
+        </p:style>
+        <p:txBody>
+          <a:bodyPr rtlCol="0" anchor="ctr"/>
+          <a:lstStyle/>
+          <a:p>
+            <a:pPr algn="ctr"/>
+          </a:p>
+        </p:txBody>
+      </p:sp>
+      <p:sp>
+        <p:nvSpPr>
+          <p:cNvPr id="4" name="Rectangle 3"/>
+          <p:cNvSpPr/>
+          <p:nvPr/>
+        </p:nvSpPr>
+        <p:spPr>
+          <a:xfrm>
+            <a:off x="0" y="228600"/>
+            <a:ext cx="9144000" cy="45720"/>
+          </a:xfrm>
+          <a:prstGeom prst="rect">
+            <a:avLst/>
+          </a:prstGeom>
+          <a:solidFill>
+            <a:srgbClr val="E0742B"/>
+          </a:solidFill>
+          <a:ln>
+            <a:noFill/>
+          </a:ln>
+          <a:effectLst/>
+        </p:spPr>
+        <p:style>
+          <a:lnRef idx="1">
+            <a:schemeClr val="accent1"/>
+          </a:lnRef>
+          <a:fillRef idx="3">
+            <a:schemeClr val="accent1"/>
+          </a:fillRef>
+          <a:effectRef idx="2">
+            <a:schemeClr val="accent1"/>
+          </a:effectRef>
+          <a:fontRef idx="minor">
+            <a:schemeClr val="lt1"/>
+          </a:fontRef>
+        </p:style>
+        <p:txBody>
+          <a:bodyPr rtlCol="0" anchor="ctr"/>
+          <a:lstStyle/>
+          <a:p>
+            <a:pPr algn="ctr"/>
+          </a:p>
+        </p:txBody>
+      </p:sp>
+      <p:sp>
+        <p:nvSpPr>
+          <p:cNvPr id="3" name="Rectangle 2"/>
+          <p:cNvSpPr/>
+          <p:nvPr/>
+        </p:nvSpPr>
+        <p:spPr>
+          <a:xfrm>
+            <a:off x="0" y="0"/>
+            <a:ext cx="9144000" cy="228600"/>
+          </a:xfrm>
+          <a:prstGeom prst="rect">
+            <a:avLst/>
+          </a:prstGeom>
+          <a:solidFill>
+            <a:srgbClr val="16213F"/>
+          </a:solidFill>
+          <a:ln>
+            <a:noFill/>
+          </a:ln>
+          <a:effectLst/>
+        </p:spPr>
+        <p:style>
+          <a:lnRef idx="1">
+            <a:schemeClr val="accent1"/>
+          </a:lnRef>
+          <a:fillRef idx="3">
+            <a:schemeClr val="accent1"/>
+          </a:fillRef>
+          <a:effectRef idx="2">
+            <a:schemeClr val="accent1"/>
+          </a:effectRef>
+          <a:fontRef idx="minor">
+            <a:schemeClr val="lt1"/>
+          </a:fontRef>
+        </p:style>
+        <p:txBody>
+          <a:bodyPr rtlCol="0" anchor="ctr"/>
+          <a:lstStyle/>
+          <a:p>
+            <a:pPr algn="ctr"/>
+          </a:p>
+        </p:txBody>
+      </p:sp>
+      <p:sp>
+        <p:nvSpPr>
+          <p:cNvPr id="2" name="Title 1"/>
+          <p:cNvSpPr>
+            <a:spLocks noGrp="1"/>
+          </p:cNvSpPr>
+          <p:nvPr>
+            <p:ph type="title"/>
+          </p:nvPr>
+        </p:nvSpPr>
+        <p:spPr/>
+        <p:txBody>
+          <a:bodyPr/>
+          <a:lstStyle/>
+          <a:p>
+            <a:r>
+              <a:t>Click to edit Master title style</a:t>
+            </a:r>
+          </a:p>
+        </p:txBody>
+      </p:sp>
+    </p:spTree>
+  </p:cSld>
+  <p:clrMapOvr>
+    <a:masterClrMapping/>
+  </p:clrMapOvr>
+</p:sld>
+</file>
+
+<file path=ppt/slides/slide11.xml><?xml version="1.0" encoding="utf-8"?>
 <p:sld xmlns:a="http://schemas.openxmlformats.org/drawingml/2006/main" xmlns:p="http://schemas.openxmlformats.org/presentationml/2006/main" xmlns:r="http://schemas.openxmlformats.org/officeDocument/2006/relationships">
   <p:cSld>
     <p:spTree>
@@ -3725,6 +4412,142 @@
           <a:lstStyle/>
           <a:p>
             <a:r>
+              <a:rPr sz="4000" b="1">
+                <a:solidFill>
+                  <a:srgbClr val="16213F"/>
+                </a:solidFill>
+              </a:rPr>
+              <a:t>Thank You</a:t>
+            </a:r>
+          </a:p>
+        </p:txBody>
+      </p:sp>
+      <p:sp>
+        <p:nvSpPr>
+          <p:cNvPr id="3" name="Text Placeholder 2"/>
+          <p:cNvSpPr>
+            <a:spLocks noGrp="1"/>
+          </p:cNvSpPr>
+          <p:nvPr>
+            <p:ph type="body" idx="1"/>
+          </p:nvPr>
+        </p:nvSpPr>
+        <p:spPr>
+          <a:xfrm>
+            <a:off x="685800" y="3429000"/>
+            <a:ext cx="7772400" cy="2286000"/>
+          </a:xfrm>
+        </p:spPr>
+        <p:txBody>
+          <a:bodyPr anchor="t"/>
+          <a:lstStyle/>
+          <a:p>
+            <a:pPr/>
+            <a:r>
+              <a:rPr sz="1800">
+                <a:solidFill>
+                  <a:srgbClr val="16213F"/>
+                </a:solidFill>
+              </a:rPr>
+              <a:t>Questions? hello@branddocs.example</a:t>
+            </a:r>
+          </a:p>
+          <a:p>
+            <a:pPr/>
+            <a:r>
+              <a:rPr sz="1800">
+                <a:solidFill>
+                  <a:srgbClr val="16213F"/>
+                </a:solidFill>
+              </a:rPr>
+              <a:t>BrandDocs Corp - synthetic sample deck.</a:t>
+            </a:r>
+          </a:p>
+        </p:txBody>
+      </p:sp>
+    </p:spTree>
+  </p:cSld>
+  <p:clrMapOvr>
+    <a:masterClrMapping/>
+  </p:clrMapOvr>
+</p:sld>
+</file>
+
+<file path=ppt/slides/slide2.xml><?xml version="1.0" encoding="utf-8"?>
+<p:sld xmlns:a="http://schemas.openxmlformats.org/drawingml/2006/main" xmlns:p="http://schemas.openxmlformats.org/presentationml/2006/main" xmlns:r="http://schemas.openxmlformats.org/officeDocument/2006/relationships">
+  <p:cSld>
+    <p:spTree>
+      <p:nvGrpSpPr>
+        <p:cNvPr id="1" name=""/>
+        <p:cNvGrpSpPr/>
+        <p:nvPr/>
+      </p:nvGrpSpPr>
+      <p:grpSpPr/>
+      <p:sp>
+        <p:nvSpPr>
+          <p:cNvPr id="4" name="Rectangle 3"/>
+          <p:cNvSpPr/>
+          <p:nvPr/>
+        </p:nvSpPr>
+        <p:spPr>
+          <a:xfrm>
+            <a:off x="457200" y="2057400"/>
+            <a:ext cx="91440" cy="3429000"/>
+          </a:xfrm>
+          <a:prstGeom prst="rect">
+            <a:avLst/>
+          </a:prstGeom>
+          <a:solidFill>
+            <a:srgbClr val="E0742B"/>
+          </a:solidFill>
+          <a:ln>
+            <a:noFill/>
+          </a:ln>
+          <a:effectLst/>
+        </p:spPr>
+        <p:style>
+          <a:lnRef idx="1">
+            <a:schemeClr val="accent1"/>
+          </a:lnRef>
+          <a:fillRef idx="3">
+            <a:schemeClr val="accent1"/>
+          </a:fillRef>
+          <a:effectRef idx="2">
+            <a:schemeClr val="accent1"/>
+          </a:effectRef>
+          <a:fontRef idx="minor">
+            <a:schemeClr val="lt1"/>
+          </a:fontRef>
+        </p:style>
+        <p:txBody>
+          <a:bodyPr rtlCol="0" anchor="ctr"/>
+          <a:lstStyle/>
+          <a:p>
+            <a:pPr algn="ctr"/>
+          </a:p>
+        </p:txBody>
+      </p:sp>
+      <p:sp>
+        <p:nvSpPr>
+          <p:cNvPr id="2" name="Title 1"/>
+          <p:cNvSpPr>
+            <a:spLocks noGrp="1"/>
+          </p:cNvSpPr>
+          <p:nvPr>
+            <p:ph type="title"/>
+          </p:nvPr>
+        </p:nvSpPr>
+        <p:spPr>
+          <a:xfrm>
+            <a:off x="685800" y="2057400"/>
+            <a:ext cx="7772400" cy="1143000"/>
+          </a:xfrm>
+        </p:spPr>
+        <p:txBody>
+          <a:bodyPr/>
+          <a:lstStyle/>
+          <a:p>
+            <a:r>
               <a:rPr sz="3600" b="1">
                 <a:solidFill>
                   <a:srgbClr val="16213F"/>
@@ -3913,6 +4736,359 @@
 </file>
 
 <file path=ppt/slides/slide4.xml><?xml version="1.0" encoding="utf-8"?>
+<p:sld xmlns:a="http://schemas.openxmlformats.org/drawingml/2006/main" xmlns:p="http://schemas.openxmlformats.org/presentationml/2006/main" xmlns:r="http://schemas.openxmlformats.org/officeDocument/2006/relationships">
+  <p:cSld>
+    <p:spTree>
+      <p:nvGrpSpPr>
+        <p:cNvPr id="1" name=""/>
+        <p:cNvGrpSpPr/>
+        <p:nvPr/>
+      </p:nvGrpSpPr>
+      <p:grpSpPr/>
+      <p:sp>
+        <p:nvSpPr>
+          <p:cNvPr id="2" name="Title 1"/>
+          <p:cNvSpPr>
+            <a:spLocks noGrp="1"/>
+          </p:cNvSpPr>
+          <p:nvPr>
+            <p:ph type="title"/>
+          </p:nvPr>
+        </p:nvSpPr>
+        <p:spPr/>
+        <p:txBody>
+          <a:bodyPr/>
+          <a:lstStyle/>
+          <a:p>
+            <a:r>
+              <a:rPr sz="3000" b="1">
+                <a:solidFill>
+                  <a:srgbClr val="16213F"/>
+                </a:solidFill>
+              </a:rPr>
+              <a:t>Performance Snapshot</a:t>
+            </a:r>
+          </a:p>
+        </p:txBody>
+      </p:sp>
+      <p:sp>
+        <p:nvSpPr>
+          <p:cNvPr id="3" name="Rounded Rectangle 2"/>
+          <p:cNvSpPr/>
+          <p:nvPr/>
+        </p:nvSpPr>
+        <p:spPr>
+          <a:xfrm>
+            <a:off x="457200" y="1371600"/>
+            <a:ext cx="1943100" cy="1005840"/>
+          </a:xfrm>
+          <a:prstGeom prst="roundRect">
+            <a:avLst/>
+          </a:prstGeom>
+          <a:solidFill>
+            <a:srgbClr val="16213F"/>
+          </a:solidFill>
+          <a:ln>
+            <a:noFill/>
+          </a:ln>
+          <a:effectLst/>
+        </p:spPr>
+        <p:style>
+          <a:lnRef idx="1">
+            <a:schemeClr val="accent1"/>
+          </a:lnRef>
+          <a:fillRef idx="3">
+            <a:schemeClr val="accent1"/>
+          </a:fillRef>
+          <a:effectRef idx="2">
+            <a:schemeClr val="accent1"/>
+          </a:effectRef>
+          <a:fontRef idx="minor">
+            <a:schemeClr val="lt1"/>
+          </a:fontRef>
+        </p:style>
+        <p:txBody>
+          <a:bodyPr rtlCol="0" anchor="ctr" lIns="137160" rIns="137160" tIns="91440" bIns="91440"/>
+          <a:lstStyle/>
+          <a:p>
+            <a:pPr algn="ctr"/>
+            <a:r>
+              <a:rPr sz="2400" b="1">
+                <a:solidFill>
+                  <a:srgbClr val="FFFFFF"/>
+                </a:solidFill>
+              </a:rPr>
+              <a:t>$14.2M</a:t>
+            </a:r>
+          </a:p>
+          <a:p>
+            <a:r>
+              <a:rPr sz="1050" b="1">
+                <a:solidFill>
+                  <a:srgbClr val="FFFFFF"/>
+                </a:solidFill>
+              </a:rPr>
+              <a:t>FY net revenue</a:t>
+            </a:r>
+          </a:p>
+        </p:txBody>
+      </p:sp>
+      <p:sp>
+        <p:nvSpPr>
+          <p:cNvPr id="4" name="Rounded Rectangle 3"/>
+          <p:cNvSpPr/>
+          <p:nvPr/>
+        </p:nvSpPr>
+        <p:spPr>
+          <a:xfrm>
+            <a:off x="2628900" y="1371600"/>
+            <a:ext cx="1943100" cy="1005840"/>
+          </a:xfrm>
+          <a:prstGeom prst="roundRect">
+            <a:avLst/>
+          </a:prstGeom>
+          <a:solidFill>
+            <a:srgbClr val="2B7CD3"/>
+          </a:solidFill>
+          <a:ln>
+            <a:noFill/>
+          </a:ln>
+          <a:effectLst/>
+        </p:spPr>
+        <p:style>
+          <a:lnRef idx="1">
+            <a:schemeClr val="accent1"/>
+          </a:lnRef>
+          <a:fillRef idx="3">
+            <a:schemeClr val="accent1"/>
+          </a:fillRef>
+          <a:effectRef idx="2">
+            <a:schemeClr val="accent1"/>
+          </a:effectRef>
+          <a:fontRef idx="minor">
+            <a:schemeClr val="lt1"/>
+          </a:fontRef>
+        </p:style>
+        <p:txBody>
+          <a:bodyPr rtlCol="0" anchor="ctr" lIns="137160" rIns="137160" tIns="91440" bIns="91440"/>
+          <a:lstStyle/>
+          <a:p>
+            <a:pPr algn="ctr"/>
+            <a:r>
+              <a:rPr sz="2400" b="1">
+                <a:solidFill>
+                  <a:srgbClr val="FFFFFF"/>
+                </a:solidFill>
+              </a:rPr>
+              <a:t>+230 bps</a:t>
+            </a:r>
+          </a:p>
+          <a:p>
+            <a:r>
+              <a:rPr sz="1050" b="1">
+                <a:solidFill>
+                  <a:srgbClr val="FFFFFF"/>
+                </a:solidFill>
+              </a:rPr>
+              <a:t>Gross margin lift</a:t>
+            </a:r>
+          </a:p>
+        </p:txBody>
+      </p:sp>
+      <p:sp>
+        <p:nvSpPr>
+          <p:cNvPr id="5" name="Rounded Rectangle 4"/>
+          <p:cNvSpPr/>
+          <p:nvPr/>
+        </p:nvSpPr>
+        <p:spPr>
+          <a:xfrm>
+            <a:off x="4800600" y="1371600"/>
+            <a:ext cx="1943100" cy="1005840"/>
+          </a:xfrm>
+          <a:prstGeom prst="roundRect">
+            <a:avLst/>
+          </a:prstGeom>
+          <a:solidFill>
+            <a:srgbClr val="EAF1FF"/>
+          </a:solidFill>
+          <a:ln>
+            <a:noFill/>
+          </a:ln>
+          <a:effectLst/>
+        </p:spPr>
+        <p:style>
+          <a:lnRef idx="1">
+            <a:schemeClr val="accent1"/>
+          </a:lnRef>
+          <a:fillRef idx="3">
+            <a:schemeClr val="accent1"/>
+          </a:fillRef>
+          <a:effectRef idx="2">
+            <a:schemeClr val="accent1"/>
+          </a:effectRef>
+          <a:fontRef idx="minor">
+            <a:schemeClr val="lt1"/>
+          </a:fontRef>
+        </p:style>
+        <p:txBody>
+          <a:bodyPr rtlCol="0" anchor="ctr" lIns="137160" rIns="137160" tIns="91440" bIns="91440"/>
+          <a:lstStyle/>
+          <a:p>
+            <a:pPr algn="ctr"/>
+            <a:r>
+              <a:rPr sz="2400" b="1">
+                <a:solidFill>
+                  <a:srgbClr val="16213F"/>
+                </a:solidFill>
+              </a:rPr>
+              <a:t>86%</a:t>
+            </a:r>
+          </a:p>
+          <a:p>
+            <a:r>
+              <a:rPr sz="1050" b="1">
+                <a:solidFill>
+                  <a:srgbClr val="5778B0"/>
+                </a:solidFill>
+              </a:rPr>
+              <a:t>Workflow adoption</a:t>
+            </a:r>
+          </a:p>
+        </p:txBody>
+      </p:sp>
+      <p:sp>
+        <p:nvSpPr>
+          <p:cNvPr id="6" name="Rounded Rectangle 5"/>
+          <p:cNvSpPr/>
+          <p:nvPr/>
+        </p:nvSpPr>
+        <p:spPr>
+          <a:xfrm>
+            <a:off x="6972300" y="1371600"/>
+            <a:ext cx="1943100" cy="1005840"/>
+          </a:xfrm>
+          <a:prstGeom prst="roundRect">
+            <a:avLst/>
+          </a:prstGeom>
+          <a:solidFill>
+            <a:srgbClr val="E0742B"/>
+          </a:solidFill>
+          <a:ln>
+            <a:noFill/>
+          </a:ln>
+          <a:effectLst/>
+        </p:spPr>
+        <p:style>
+          <a:lnRef idx="1">
+            <a:schemeClr val="accent1"/>
+          </a:lnRef>
+          <a:fillRef idx="3">
+            <a:schemeClr val="accent1"/>
+          </a:fillRef>
+          <a:effectRef idx="2">
+            <a:schemeClr val="accent1"/>
+          </a:effectRef>
+          <a:fontRef idx="minor">
+            <a:schemeClr val="lt1"/>
+          </a:fontRef>
+        </p:style>
+        <p:txBody>
+          <a:bodyPr rtlCol="0" anchor="ctr" lIns="137160" rIns="137160" tIns="91440" bIns="91440"/>
+          <a:lstStyle/>
+          <a:p>
+            <a:pPr algn="ctr"/>
+            <a:r>
+              <a:rPr sz="2400" b="1">
+                <a:solidFill>
+                  <a:srgbClr val="FFFFFF"/>
+                </a:solidFill>
+              </a:rPr>
+              <a:t>4</a:t>
+            </a:r>
+          </a:p>
+          <a:p>
+            <a:r>
+              <a:rPr sz="1050" b="1">
+                <a:solidFill>
+                  <a:srgbClr val="FFFFFF"/>
+                </a:solidFill>
+              </a:rPr>
+              <a:t>Priority risks</a:t>
+            </a:r>
+          </a:p>
+        </p:txBody>
+      </p:sp>
+      <p:graphicFrame>
+        <p:nvGraphicFramePr>
+          <p:cNvPr id="7" name="Chart 6"/>
+          <p:cNvGraphicFramePr>
+            <a:graphicFrameLocks noGrp="1"/>
+          </p:cNvGraphicFramePr>
+          <p:nvPr/>
+        </p:nvGraphicFramePr>
+        <p:xfrm>
+          <a:off x="685800" y="2926080"/>
+          <a:ext cx="5486400" cy="2743200"/>
+        </p:xfrm>
+        <a:graphic>
+          <a:graphicData uri="http://schemas.openxmlformats.org/drawingml/2006/chart">
+            <c:chart xmlns:c="http://schemas.openxmlformats.org/drawingml/2006/chart" r:id="rId2"/>
+          </a:graphicData>
+        </a:graphic>
+      </p:graphicFrame>
+      <p:sp>
+        <p:nvSpPr>
+          <p:cNvPr id="8" name="TextBox 7"/>
+          <p:cNvSpPr txBox="1"/>
+          <p:nvPr/>
+        </p:nvSpPr>
+        <p:spPr>
+          <a:xfrm>
+            <a:off x="6537960" y="3017520"/>
+            <a:ext cx="2286000" cy="2286000"/>
+          </a:xfrm>
+          <a:prstGeom prst="rect">
+            <a:avLst/>
+          </a:prstGeom>
+          <a:noFill/>
+        </p:spPr>
+        <p:txBody>
+          <a:bodyPr wrap="square" lIns="137160">
+            <a:spAutoFit/>
+          </a:bodyPr>
+          <a:lstStyle/>
+          <a:p>
+            <a:r>
+              <a:rPr b="1" sz="1600">
+                <a:solidFill>
+                  <a:srgbClr val="16213F"/>
+                </a:solidFill>
+              </a:rPr>
+              <a:t>Primary signal</a:t>
+            </a:r>
+          </a:p>
+          <a:p>
+            <a:r>
+              <a:rPr sz="1300">
+                <a:solidFill>
+                  <a:srgbClr val="5778B0"/>
+                </a:solidFill>
+              </a:rPr>
+              <a:t>Outputs now carry visual proof artifacts, moving QA from spot-checking to repeatable evidence.</a:t>
+            </a:r>
+          </a:p>
+        </p:txBody>
+      </p:sp>
+    </p:spTree>
+  </p:cSld>
+  <p:clrMapOvr>
+    <a:masterClrMapping/>
+  </p:clrMapOvr>
+</p:sld>
+</file>
+
+<file path=ppt/slides/slide5.xml><?xml version="1.0" encoding="utf-8"?>
 <p:sld xmlns:a="http://schemas.openxmlformats.org/drawingml/2006/main" xmlns:p="http://schemas.openxmlformats.org/presentationml/2006/main" xmlns:r="http://schemas.openxmlformats.org/officeDocument/2006/relationships">
   <p:cSld>
     <p:spTree>
@@ -4520,7 +5696,7 @@
 </p:sld>
 </file>
 
-<file path=ppt/slides/slide5.xml><?xml version="1.0" encoding="utf-8"?>
+<file path=ppt/slides/slide6.xml><?xml version="1.0" encoding="utf-8"?>
 <p:sld xmlns:a="http://schemas.openxmlformats.org/drawingml/2006/main" xmlns:p="http://schemas.openxmlformats.org/presentationml/2006/main" xmlns:r="http://schemas.openxmlformats.org/officeDocument/2006/relationships">
   <p:cSld>
     <p:spTree>
@@ -4582,7 +5758,7 @@
 </p:sld>
 </file>
 
-<file path=ppt/slides/slide6.xml><?xml version="1.0" encoding="utf-8"?>
+<file path=ppt/slides/slide7.xml><?xml version="1.0" encoding="utf-8"?>
 <p:sld xmlns:a="http://schemas.openxmlformats.org/drawingml/2006/main" xmlns:p="http://schemas.openxmlformats.org/presentationml/2006/main" xmlns:r="http://schemas.openxmlformats.org/officeDocument/2006/relationships">
   <p:cSld>
     <p:spTree>
@@ -4602,6 +5778,508 @@
             <p:ph type="title"/>
           </p:nvPr>
         </p:nvSpPr>
+        <p:spPr/>
+        <p:txBody>
+          <a:bodyPr/>
+          <a:lstStyle/>
+          <a:p>
+            <a:r>
+              <a:rPr sz="2800" b="1">
+                <a:solidFill>
+                  <a:srgbClr val="16213F"/>
+                </a:solidFill>
+              </a:rPr>
+              <a:t>Risk &amp; Readiness Heatmap</a:t>
+            </a:r>
+          </a:p>
+        </p:txBody>
+      </p:sp>
+      <p:graphicFrame>
+        <p:nvGraphicFramePr>
+          <p:cNvPr id="3" name="Table 2"/>
+          <p:cNvGraphicFramePr>
+            <a:graphicFrameLocks noGrp="1"/>
+          </p:cNvGraphicFramePr>
+          <p:nvPr/>
+        </p:nvGraphicFramePr>
+        <p:xfrm>
+          <a:off x="685800" y="1600200"/>
+          <a:ext cx="7772400" cy="3657600"/>
+        </p:xfrm>
+        <a:graphic>
+          <a:graphicData uri="http://schemas.openxmlformats.org/drawingml/2006/table">
+            <a:tbl>
+              <a:tblPr firstRow="1" bandRow="1">
+                <a:tableStyleId>{5C22544A-7EE6-4342-B048-85BDC9FD1C3A}</a:tableStyleId>
+              </a:tblPr>
+              <a:tblGrid>
+                <a:gridCol w="1943100"/>
+                <a:gridCol w="1943100"/>
+                <a:gridCol w="1943100"/>
+                <a:gridCol w="1943100"/>
+              </a:tblGrid>
+              <a:tr h="731520">
+                <a:tc>
+                  <a:txBody>
+                    <a:bodyPr/>
+                    <a:lstStyle/>
+                    <a:p>
+                      <a:r>
+                        <a:rPr b="1" sz="1300">
+                          <a:solidFill>
+                            <a:srgbClr val="FFFFFF"/>
+                          </a:solidFill>
+                        </a:rPr>
+                        <a:t>Area</a:t>
+                      </a:r>
+                    </a:p>
+                  </a:txBody>
+                  <a:tcPr>
+                    <a:solidFill>
+                      <a:srgbClr val="16213F"/>
+                    </a:solidFill>
+                  </a:tcPr>
+                </a:tc>
+                <a:tc>
+                  <a:txBody>
+                    <a:bodyPr/>
+                    <a:lstStyle/>
+                    <a:p>
+                      <a:r>
+                        <a:rPr b="1" sz="1300">
+                          <a:solidFill>
+                            <a:srgbClr val="FFFFFF"/>
+                          </a:solidFill>
+                        </a:rPr>
+                        <a:t>Signal</a:t>
+                      </a:r>
+                    </a:p>
+                  </a:txBody>
+                  <a:tcPr>
+                    <a:solidFill>
+                      <a:srgbClr val="16213F"/>
+                    </a:solidFill>
+                  </a:tcPr>
+                </a:tc>
+                <a:tc>
+                  <a:txBody>
+                    <a:bodyPr/>
+                    <a:lstStyle/>
+                    <a:p>
+                      <a:r>
+                        <a:rPr b="1" sz="1300">
+                          <a:solidFill>
+                            <a:srgbClr val="FFFFFF"/>
+                          </a:solidFill>
+                        </a:rPr>
+                        <a:t>Readiness</a:t>
+                      </a:r>
+                    </a:p>
+                  </a:txBody>
+                  <a:tcPr>
+                    <a:solidFill>
+                      <a:srgbClr val="16213F"/>
+                    </a:solidFill>
+                  </a:tcPr>
+                </a:tc>
+                <a:tc>
+                  <a:txBody>
+                    <a:bodyPr/>
+                    <a:lstStyle/>
+                    <a:p>
+                      <a:r>
+                        <a:rPr b="1" sz="1300">
+                          <a:solidFill>
+                            <a:srgbClr val="FFFFFF"/>
+                          </a:solidFill>
+                        </a:rPr>
+                        <a:t>Action</a:t>
+                      </a:r>
+                    </a:p>
+                  </a:txBody>
+                  <a:tcPr>
+                    <a:solidFill>
+                      <a:srgbClr val="16213F"/>
+                    </a:solidFill>
+                  </a:tcPr>
+                </a:tc>
+              </a:tr>
+              <a:tr h="731520">
+                <a:tc>
+                  <a:txBody>
+                    <a:bodyPr/>
+                    <a:lstStyle/>
+                    <a:p>
+                      <a:r>
+                        <a:rPr sz="1200" b="0">
+                          <a:solidFill>
+                            <a:srgbClr val="16213F"/>
+                          </a:solidFill>
+                        </a:rPr>
+                        <a:t>Renderer</a:t>
+                      </a:r>
+                    </a:p>
+                  </a:txBody>
+                  <a:tcPr>
+                    <a:solidFill>
+                      <a:srgbClr val="EAF1FF"/>
+                    </a:solidFill>
+                  </a:tcPr>
+                </a:tc>
+                <a:tc>
+                  <a:txBody>
+                    <a:bodyPr/>
+                    <a:lstStyle/>
+                    <a:p>
+                      <a:r>
+                        <a:rPr sz="1200" b="0">
+                          <a:solidFill>
+                            <a:srgbClr val="16213F"/>
+                          </a:solidFill>
+                        </a:rPr>
+                        <a:t>Sandbox drift</a:t>
+                      </a:r>
+                    </a:p>
+                  </a:txBody>
+                  <a:tcPr>
+                    <a:solidFill>
+                      <a:srgbClr val="EAF1FF"/>
+                    </a:solidFill>
+                  </a:tcPr>
+                </a:tc>
+                <a:tc>
+                  <a:txBody>
+                    <a:bodyPr/>
+                    <a:lstStyle/>
+                    <a:p>
+                      <a:r>
+                        <a:rPr sz="1200" b="1">
+                          <a:solidFill>
+                            <a:srgbClr val="FFFFFF"/>
+                          </a:solidFill>
+                        </a:rPr>
+                        <a:t>Amber</a:t>
+                      </a:r>
+                    </a:p>
+                  </a:txBody>
+                  <a:tcPr>
+                    <a:solidFill>
+                      <a:srgbClr val="E0742B"/>
+                    </a:solidFill>
+                  </a:tcPr>
+                </a:tc>
+                <a:tc>
+                  <a:txBody>
+                    <a:bodyPr/>
+                    <a:lstStyle/>
+                    <a:p>
+                      <a:r>
+                        <a:rPr sz="1200" b="0">
+                          <a:solidFill>
+                            <a:srgbClr val="16213F"/>
+                          </a:solidFill>
+                        </a:rPr>
+                        <a:t>Run doctor before deep QA</a:t>
+                      </a:r>
+                    </a:p>
+                  </a:txBody>
+                  <a:tcPr>
+                    <a:solidFill>
+                      <a:srgbClr val="EAF1FF"/>
+                    </a:solidFill>
+                  </a:tcPr>
+                </a:tc>
+              </a:tr>
+              <a:tr h="731520">
+                <a:tc>
+                  <a:txBody>
+                    <a:bodyPr/>
+                    <a:lstStyle/>
+                    <a:p>
+                      <a:r>
+                        <a:rPr sz="1200" b="0">
+                          <a:solidFill>
+                            <a:srgbClr val="16213F"/>
+                          </a:solidFill>
+                        </a:rPr>
+                        <a:t>Template</a:t>
+                      </a:r>
+                    </a:p>
+                  </a:txBody>
+                  <a:tcPr>
+                    <a:solidFill>
+                      <a:srgbClr val="EAF1FF"/>
+                    </a:solidFill>
+                  </a:tcPr>
+                </a:tc>
+                <a:tc>
+                  <a:txBody>
+                    <a:bodyPr/>
+                    <a:lstStyle/>
+                    <a:p>
+                      <a:r>
+                        <a:rPr sz="1200" b="0">
+                          <a:solidFill>
+                            <a:srgbClr val="16213F"/>
+                          </a:solidFill>
+                        </a:rPr>
+                        <a:t>Stale field cache</a:t>
+                      </a:r>
+                    </a:p>
+                  </a:txBody>
+                  <a:tcPr>
+                    <a:solidFill>
+                      <a:srgbClr val="EAF1FF"/>
+                    </a:solidFill>
+                  </a:tcPr>
+                </a:tc>
+                <a:tc>
+                  <a:txBody>
+                    <a:bodyPr/>
+                    <a:lstStyle/>
+                    <a:p>
+                      <a:r>
+                        <a:rPr sz="1200" b="1">
+                          <a:solidFill>
+                            <a:srgbClr val="FFFFFF"/>
+                          </a:solidFill>
+                        </a:rPr>
+                        <a:t>Teal</a:t>
+                      </a:r>
+                    </a:p>
+                  </a:txBody>
+                  <a:tcPr>
+                    <a:solidFill>
+                      <a:srgbClr val="2B7CD3"/>
+                    </a:solidFill>
+                  </a:tcPr>
+                </a:tc>
+                <a:tc>
+                  <a:txBody>
+                    <a:bodyPr/>
+                    <a:lstStyle/>
+                    <a:p>
+                      <a:r>
+                        <a:rPr sz="1200" b="0">
+                          <a:solidFill>
+                            <a:srgbClr val="16213F"/>
+                          </a:solidFill>
+                        </a:rPr>
+                        <a:t>Refresh generated indexes</a:t>
+                      </a:r>
+                    </a:p>
+                  </a:txBody>
+                  <a:tcPr>
+                    <a:solidFill>
+                      <a:srgbClr val="EAF1FF"/>
+                    </a:solidFill>
+                  </a:tcPr>
+                </a:tc>
+              </a:tr>
+              <a:tr h="731520">
+                <a:tc>
+                  <a:txBody>
+                    <a:bodyPr/>
+                    <a:lstStyle/>
+                    <a:p>
+                      <a:r>
+                        <a:rPr sz="1200" b="0">
+                          <a:solidFill>
+                            <a:srgbClr val="16213F"/>
+                          </a:solidFill>
+                        </a:rPr>
+                        <a:t>Workbook</a:t>
+                      </a:r>
+                    </a:p>
+                  </a:txBody>
+                  <a:tcPr>
+                    <a:solidFill>
+                      <a:srgbClr val="EAF1FF"/>
+                    </a:solidFill>
+                  </a:tcPr>
+                </a:tc>
+                <a:tc>
+                  <a:txBody>
+                    <a:bodyPr/>
+                    <a:lstStyle/>
+                    <a:p>
+                      <a:r>
+                        <a:rPr sz="1200" b="0">
+                          <a:solidFill>
+                            <a:srgbClr val="16213F"/>
+                          </a:solidFill>
+                        </a:rPr>
+                        <a:t>Formula loss</a:t>
+                      </a:r>
+                    </a:p>
+                  </a:txBody>
+                  <a:tcPr>
+                    <a:solidFill>
+                      <a:srgbClr val="EAF1FF"/>
+                    </a:solidFill>
+                  </a:tcPr>
+                </a:tc>
+                <a:tc>
+                  <a:txBody>
+                    <a:bodyPr/>
+                    <a:lstStyle/>
+                    <a:p>
+                      <a:r>
+                        <a:rPr sz="1200" b="1">
+                          <a:solidFill>
+                            <a:srgbClr val="FFFFFF"/>
+                          </a:solidFill>
+                        </a:rPr>
+                        <a:t>Navy</a:t>
+                      </a:r>
+                    </a:p>
+                  </a:txBody>
+                  <a:tcPr>
+                    <a:solidFill>
+                      <a:srgbClr val="16213F"/>
+                    </a:solidFill>
+                  </a:tcPr>
+                </a:tc>
+                <a:tc>
+                  <a:txBody>
+                    <a:bodyPr/>
+                    <a:lstStyle/>
+                    <a:p>
+                      <a:r>
+                        <a:rPr sz="1200" b="0">
+                          <a:solidFill>
+                            <a:srgbClr val="16213F"/>
+                          </a:solidFill>
+                        </a:rPr>
+                        <a:t>Diff formulas shell vs output</a:t>
+                      </a:r>
+                    </a:p>
+                  </a:txBody>
+                  <a:tcPr>
+                    <a:solidFill>
+                      <a:srgbClr val="EAF1FF"/>
+                    </a:solidFill>
+                  </a:tcPr>
+                </a:tc>
+              </a:tr>
+              <a:tr h="731520">
+                <a:tc>
+                  <a:txBody>
+                    <a:bodyPr/>
+                    <a:lstStyle/>
+                    <a:p>
+                      <a:r>
+                        <a:rPr sz="1200" b="0">
+                          <a:solidFill>
+                            <a:srgbClr val="16213F"/>
+                          </a:solidFill>
+                        </a:rPr>
+                        <a:t>Deck</a:t>
+                      </a:r>
+                    </a:p>
+                  </a:txBody>
+                  <a:tcPr>
+                    <a:solidFill>
+                      <a:srgbClr val="EAF1FF"/>
+                    </a:solidFill>
+                  </a:tcPr>
+                </a:tc>
+                <a:tc>
+                  <a:txBody>
+                    <a:bodyPr/>
+                    <a:lstStyle/>
+                    <a:p>
+                      <a:r>
+                        <a:rPr sz="1200" b="0">
+                          <a:solidFill>
+                            <a:srgbClr val="16213F"/>
+                          </a:solidFill>
+                        </a:rPr>
+                        <a:t>Native object loss</a:t>
+                      </a:r>
+                    </a:p>
+                  </a:txBody>
+                  <a:tcPr>
+                    <a:solidFill>
+                      <a:srgbClr val="EAF1FF"/>
+                    </a:solidFill>
+                  </a:tcPr>
+                </a:tc>
+                <a:tc>
+                  <a:txBody>
+                    <a:bodyPr/>
+                    <a:lstStyle/>
+                    <a:p>
+                      <a:r>
+                        <a:rPr sz="1200" b="1">
+                          <a:solidFill>
+                            <a:srgbClr val="FFFFFF"/>
+                          </a:solidFill>
+                        </a:rPr>
+                        <a:t>Amber</a:t>
+                      </a:r>
+                    </a:p>
+                  </a:txBody>
+                  <a:tcPr>
+                    <a:solidFill>
+                      <a:srgbClr val="E0742B"/>
+                    </a:solidFill>
+                  </a:tcPr>
+                </a:tc>
+                <a:tc>
+                  <a:txBody>
+                    <a:bodyPr/>
+                    <a:lstStyle/>
+                    <a:p>
+                      <a:r>
+                        <a:rPr sz="1200" b="0">
+                          <a:solidFill>
+                            <a:srgbClr val="16213F"/>
+                          </a:solidFill>
+                        </a:rPr>
+                        <a:t>Review component warnings</a:t>
+                      </a:r>
+                    </a:p>
+                  </a:txBody>
+                  <a:tcPr>
+                    <a:solidFill>
+                      <a:srgbClr val="EAF1FF"/>
+                    </a:solidFill>
+                  </a:tcPr>
+                </a:tc>
+              </a:tr>
+            </a:tbl>
+          </a:graphicData>
+        </a:graphic>
+      </p:graphicFrame>
+    </p:spTree>
+  </p:cSld>
+  <p:clrMapOvr>
+    <a:masterClrMapping/>
+  </p:clrMapOvr>
+</p:sld>
+</file>
+
+<file path=ppt/slides/slide8.xml><?xml version="1.0" encoding="utf-8"?>
+<p:sld xmlns:a="http://schemas.openxmlformats.org/drawingml/2006/main" xmlns:p="http://schemas.openxmlformats.org/presentationml/2006/main" xmlns:r="http://schemas.openxmlformats.org/officeDocument/2006/relationships">
+  <p:cSld>
+    <p:spTree>
+      <p:nvGrpSpPr>
+        <p:cNvPr id="1" name=""/>
+        <p:cNvGrpSpPr/>
+        <p:nvPr/>
+      </p:nvGrpSpPr>
+      <p:grpSpPr/>
+      <p:sp>
+        <p:nvSpPr>
+          <p:cNvPr id="2" name="Title 1"/>
+          <p:cNvSpPr>
+            <a:spLocks noGrp="1"/>
+          </p:cNvSpPr>
+          <p:nvPr>
+            <p:ph type="title"/>
+          </p:nvPr>
+        </p:nvSpPr>
         <p:spPr>
           <a:xfrm>
             <a:off x="0" y="3429000"/>
@@ -4617,14 +6295,14 @@
                   <a:srgbClr val="16213F"/>
                 </a:solidFill>
               </a:rPr>
-              <a:t>The BrandDocs Brand Mark</a:t>
+              <a:t>The BrandDocs Wordmark</a:t>
             </a:r>
           </a:p>
         </p:txBody>
       </p:sp>
       <p:pic>
         <p:nvPicPr>
-          <p:cNvPr id="3" name="Picture Placeholder 2" descr="branddocs_template_mark.png"/>
+          <p:cNvPr id="3" name="Picture Placeholder 2" descr="branddocs_template_wordmark.png"/>
           <p:cNvPicPr>
             <a:picLocks noGrp="1" noChangeAspect="1"/>
           </p:cNvPicPr>
@@ -4641,8 +6319,8 @@
         </p:blipFill>
         <p:spPr>
           <a:xfrm>
-            <a:off x="3429000" y="914400"/>
-            <a:ext cx="2286000" cy="2286000"/>
+            <a:off x="1828800" y="1371600"/>
+            <a:ext cx="4754880" cy="1188720"/>
           </a:xfrm>
         </p:spPr>
       </p:pic>
@@ -4672,7 +6350,7 @@
                   <a:srgbClr val="16213F"/>
                 </a:solidFill>
               </a:rPr>
-              <a:t>A synthetic, generated mark - no proprietary asset.</a:t>
+              <a:t>A synthetic, generated logo - no proprietary asset.</a:t>
             </a:r>
           </a:p>
           <a:p>
@@ -4683,14 +6361,14 @@
                   <a:srgbClr val="16213F"/>
                 </a:solidFill>
               </a:rPr>
-              <a:t>Navy rounded tile, blue stroke, blue header bar, outlined field.</a:t>
+              <a:t>The logo is simply the BrandDocs name, with no icon or badge.</a:t>
             </a:r>
           </a:p>
         </p:txBody>
       </p:sp>
       <p:pic>
         <p:nvPicPr>
-          <p:cNvPr id="5" name="Picture 4" descr="branddocs_template_mark.png"/>
+          <p:cNvPr id="5" name="Picture 4" descr="branddocs_template_wordmark.png"/>
           <p:cNvPicPr>
             <a:picLocks noChangeAspect="1"/>
           </p:cNvPicPr>
@@ -4704,8 +6382,8 @@
         </p:blipFill>
         <p:spPr>
           <a:xfrm>
-            <a:off x="457200" y="457200"/>
-            <a:ext cx="457200" cy="457200"/>
+            <a:off x="457200" y="548640"/>
+            <a:ext cx="1371600" cy="342900"/>
           </a:xfrm>
           <a:prstGeom prst="rect">
             <a:avLst/>
@@ -4720,7 +6398,7 @@
 </p:sld>
 </file>
 
-<file path=ppt/slides/slide7.xml><?xml version="1.0" encoding="utf-8"?>
+<file path=ppt/slides/slide9.xml><?xml version="1.0" encoding="utf-8"?>
 <p:sld xmlns:a="http://schemas.openxmlformats.org/drawingml/2006/main" xmlns:p="http://schemas.openxmlformats.org/presentationml/2006/main" xmlns:r="http://schemas.openxmlformats.org/officeDocument/2006/relationships">
   <p:cSld>
     <p:spTree>
@@ -5086,313 +6764,6 @@
                 </a:solidFill>
               </a:rPr>
               <a:t>Grow to new regions</a:t>
-            </a:r>
-          </a:p>
-        </p:txBody>
-      </p:sp>
-    </p:spTree>
-  </p:cSld>
-  <p:clrMapOvr>
-    <a:masterClrMapping/>
-  </p:clrMapOvr>
-</p:sld>
-</file>
-
-<file path=ppt/slides/slide8.xml><?xml version="1.0" encoding="utf-8"?>
-<p:sld xmlns:a="http://schemas.openxmlformats.org/drawingml/2006/main" xmlns:p="http://schemas.openxmlformats.org/presentationml/2006/main" xmlns:r="http://schemas.openxmlformats.org/officeDocument/2006/relationships">
-  <p:cSld>
-    <p:spTree>
-      <p:nvGrpSpPr>
-        <p:cNvPr id="1" name=""/>
-        <p:cNvGrpSpPr/>
-        <p:nvPr/>
-      </p:nvGrpSpPr>
-      <p:grpSpPr/>
-      <p:sp>
-        <p:nvSpPr>
-          <p:cNvPr id="5" name="Rectangle 4"/>
-          <p:cNvSpPr/>
-          <p:nvPr/>
-        </p:nvSpPr>
-        <p:spPr>
-          <a:xfrm>
-            <a:off x="0" y="6629400"/>
-            <a:ext cx="9144000" cy="228600"/>
-          </a:xfrm>
-          <a:prstGeom prst="rect">
-            <a:avLst/>
-          </a:prstGeom>
-          <a:solidFill>
-            <a:srgbClr val="16213F"/>
-          </a:solidFill>
-          <a:ln>
-            <a:noFill/>
-          </a:ln>
-          <a:effectLst/>
-        </p:spPr>
-        <p:style>
-          <a:lnRef idx="1">
-            <a:schemeClr val="accent1"/>
-          </a:lnRef>
-          <a:fillRef idx="3">
-            <a:schemeClr val="accent1"/>
-          </a:fillRef>
-          <a:effectRef idx="2">
-            <a:schemeClr val="accent1"/>
-          </a:effectRef>
-          <a:fontRef idx="minor">
-            <a:schemeClr val="lt1"/>
-          </a:fontRef>
-        </p:style>
-        <p:txBody>
-          <a:bodyPr rtlCol="0" anchor="ctr"/>
-          <a:lstStyle/>
-          <a:p>
-            <a:pPr algn="ctr"/>
-          </a:p>
-        </p:txBody>
-      </p:sp>
-      <p:sp>
-        <p:nvSpPr>
-          <p:cNvPr id="4" name="Rectangle 3"/>
-          <p:cNvSpPr/>
-          <p:nvPr/>
-        </p:nvSpPr>
-        <p:spPr>
-          <a:xfrm>
-            <a:off x="0" y="228600"/>
-            <a:ext cx="9144000" cy="45720"/>
-          </a:xfrm>
-          <a:prstGeom prst="rect">
-            <a:avLst/>
-          </a:prstGeom>
-          <a:solidFill>
-            <a:srgbClr val="E0742B"/>
-          </a:solidFill>
-          <a:ln>
-            <a:noFill/>
-          </a:ln>
-          <a:effectLst/>
-        </p:spPr>
-        <p:style>
-          <a:lnRef idx="1">
-            <a:schemeClr val="accent1"/>
-          </a:lnRef>
-          <a:fillRef idx="3">
-            <a:schemeClr val="accent1"/>
-          </a:fillRef>
-          <a:effectRef idx="2">
-            <a:schemeClr val="accent1"/>
-          </a:effectRef>
-          <a:fontRef idx="minor">
-            <a:schemeClr val="lt1"/>
-          </a:fontRef>
-        </p:style>
-        <p:txBody>
-          <a:bodyPr rtlCol="0" anchor="ctr"/>
-          <a:lstStyle/>
-          <a:p>
-            <a:pPr algn="ctr"/>
-          </a:p>
-        </p:txBody>
-      </p:sp>
-      <p:sp>
-        <p:nvSpPr>
-          <p:cNvPr id="3" name="Rectangle 2"/>
-          <p:cNvSpPr/>
-          <p:nvPr/>
-        </p:nvSpPr>
-        <p:spPr>
-          <a:xfrm>
-            <a:off x="0" y="0"/>
-            <a:ext cx="9144000" cy="228600"/>
-          </a:xfrm>
-          <a:prstGeom prst="rect">
-            <a:avLst/>
-          </a:prstGeom>
-          <a:solidFill>
-            <a:srgbClr val="16213F"/>
-          </a:solidFill>
-          <a:ln>
-            <a:noFill/>
-          </a:ln>
-          <a:effectLst/>
-        </p:spPr>
-        <p:style>
-          <a:lnRef idx="1">
-            <a:schemeClr val="accent1"/>
-          </a:lnRef>
-          <a:fillRef idx="3">
-            <a:schemeClr val="accent1"/>
-          </a:fillRef>
-          <a:effectRef idx="2">
-            <a:schemeClr val="accent1"/>
-          </a:effectRef>
-          <a:fontRef idx="minor">
-            <a:schemeClr val="lt1"/>
-          </a:fontRef>
-        </p:style>
-        <p:txBody>
-          <a:bodyPr rtlCol="0" anchor="ctr"/>
-          <a:lstStyle/>
-          <a:p>
-            <a:pPr algn="ctr"/>
-          </a:p>
-        </p:txBody>
-      </p:sp>
-      <p:sp>
-        <p:nvSpPr>
-          <p:cNvPr id="2" name="Title 1"/>
-          <p:cNvSpPr>
-            <a:spLocks noGrp="1"/>
-          </p:cNvSpPr>
-          <p:nvPr>
-            <p:ph type="title"/>
-          </p:nvPr>
-        </p:nvSpPr>
-        <p:spPr/>
-        <p:txBody>
-          <a:bodyPr/>
-          <a:lstStyle/>
-          <a:p>
-            <a:r>
-              <a:t>Click to edit Master title style</a:t>
-            </a:r>
-          </a:p>
-        </p:txBody>
-      </p:sp>
-    </p:spTree>
-  </p:cSld>
-  <p:clrMapOvr>
-    <a:masterClrMapping/>
-  </p:clrMapOvr>
-</p:sld>
-</file>
-
-<file path=ppt/slides/slide9.xml><?xml version="1.0" encoding="utf-8"?>
-<p:sld xmlns:a="http://schemas.openxmlformats.org/drawingml/2006/main" xmlns:p="http://schemas.openxmlformats.org/presentationml/2006/main" xmlns:r="http://schemas.openxmlformats.org/officeDocument/2006/relationships">
-  <p:cSld>
-    <p:spTree>
-      <p:nvGrpSpPr>
-        <p:cNvPr id="1" name=""/>
-        <p:cNvGrpSpPr/>
-        <p:nvPr/>
-      </p:nvGrpSpPr>
-      <p:grpSpPr/>
-      <p:sp>
-        <p:nvSpPr>
-          <p:cNvPr id="4" name="Rectangle 3"/>
-          <p:cNvSpPr/>
-          <p:nvPr/>
-        </p:nvSpPr>
-        <p:spPr>
-          <a:xfrm>
-            <a:off x="457200" y="2057400"/>
-            <a:ext cx="91440" cy="3429000"/>
-          </a:xfrm>
-          <a:prstGeom prst="rect">
-            <a:avLst/>
-          </a:prstGeom>
-          <a:solidFill>
-            <a:srgbClr val="E0742B"/>
-          </a:solidFill>
-          <a:ln>
-            <a:noFill/>
-          </a:ln>
-          <a:effectLst/>
-        </p:spPr>
-        <p:style>
-          <a:lnRef idx="1">
-            <a:schemeClr val="accent1"/>
-          </a:lnRef>
-          <a:fillRef idx="3">
-            <a:schemeClr val="accent1"/>
-          </a:fillRef>
-          <a:effectRef idx="2">
-            <a:schemeClr val="accent1"/>
-          </a:effectRef>
-          <a:fontRef idx="minor">
-            <a:schemeClr val="lt1"/>
-          </a:fontRef>
-        </p:style>
-        <p:txBody>
-          <a:bodyPr rtlCol="0" anchor="ctr"/>
-          <a:lstStyle/>
-          <a:p>
-            <a:pPr algn="ctr"/>
-          </a:p>
-        </p:txBody>
-      </p:sp>
-      <p:sp>
-        <p:nvSpPr>
-          <p:cNvPr id="2" name="Title 1"/>
-          <p:cNvSpPr>
-            <a:spLocks noGrp="1"/>
-          </p:cNvSpPr>
-          <p:nvPr>
-            <p:ph type="title"/>
-          </p:nvPr>
-        </p:nvSpPr>
-        <p:spPr>
-          <a:xfrm>
-            <a:off x="685800" y="2057400"/>
-            <a:ext cx="7772400" cy="1143000"/>
-          </a:xfrm>
-        </p:spPr>
-        <p:txBody>
-          <a:bodyPr/>
-          <a:lstStyle/>
-          <a:p>
-            <a:r>
-              <a:rPr sz="4000" b="1">
-                <a:solidFill>
-                  <a:srgbClr val="16213F"/>
-                </a:solidFill>
-              </a:rPr>
-              <a:t>Thank You</a:t>
-            </a:r>
-          </a:p>
-        </p:txBody>
-      </p:sp>
-      <p:sp>
-        <p:nvSpPr>
-          <p:cNvPr id="3" name="Text Placeholder 2"/>
-          <p:cNvSpPr>
-            <a:spLocks noGrp="1"/>
-          </p:cNvSpPr>
-          <p:nvPr>
-            <p:ph type="body" idx="1"/>
-          </p:nvPr>
-        </p:nvSpPr>
-        <p:spPr>
-          <a:xfrm>
-            <a:off x="685800" y="3429000"/>
-            <a:ext cx="7772400" cy="2286000"/>
-          </a:xfrm>
-        </p:spPr>
-        <p:txBody>
-          <a:bodyPr anchor="t"/>
-          <a:lstStyle/>
-          <a:p>
-            <a:pPr/>
-            <a:r>
-              <a:rPr sz="1800">
-                <a:solidFill>
-                  <a:srgbClr val="16213F"/>
-                </a:solidFill>
-              </a:rPr>
-              <a:t>Questions? hello@branddocs.example</a:t>
-            </a:r>
-          </a:p>
-          <a:p>
-            <a:pPr/>
-            <a:r>
-              <a:rPr sz="1800">
-                <a:solidFill>
-                  <a:srgbClr val="16213F"/>
-                </a:solidFill>
-              </a:rPr>
-              <a:t>BrandDocs Corp - synthetic sample deck.</a:t>
             </a:r>
           </a:p>
         </p:txBody>

</xml_diff>